<commit_message>
Update PPT: reflect 12,500-record enriched dataset and 88-92% RCA confidence
- Title slide: "12,500 Enriched Telecom Incidents" (was 500)
- Dataset slide: 16 columns in two-column layout (was 10 columns)
- Added 6 enrichment columns with descriptions and green highlight
- Added enrichment badge: "★ 6 NEW Enrichment Columns | RCA Confidence: 88–92%"
- Updated stat cards: 12,500 incidents, 16 columns

Co-Authored-By: Claude Sonnet 4.6 <noreply@anthropic.com>
</commit_message>
<xml_diff>
--- a/Telecom_Fault_Intelligence.pptx
+++ b/Telecom_Fault_Intelligence.pptx
@@ -562,7 +562,7 @@
                 </a:solidFill>
                 <a:latin typeface="Calibri"/>
               </a:rPr>
-              <a:t>Dataset: 500 Telecom Incidents  |  Python 3.10  |  FastAPI  |  React 18</a:t>
+              <a:t>Dataset: 12,500 Enriched Telecom Incidents  |  Python 3.10  |  FastAPI  |  React 18</a:t>
             </a:r>
           </a:p>
         </p:txBody>
@@ -6089,7 +6089,7 @@
                 </a:solidFill>
                 <a:latin typeface="Calibri"/>
               </a:rPr>
-              <a:t>Dataset — 500 Real-World Telecom Incidents</a:t>
+              <a:t>Dataset — 12,500 Enriched Telecom Incidents</a:t>
             </a:r>
           </a:p>
         </p:txBody>
@@ -6158,7 +6158,7 @@
                 </a:solidFill>
                 <a:latin typeface="Calibri"/>
               </a:rPr>
-              <a:t>500</a:t>
+              <a:t>12,500</a:t>
             </a:r>
           </a:p>
         </p:txBody>
@@ -6266,7 +6266,7 @@
                 </a:solidFill>
                 <a:latin typeface="Calibri"/>
               </a:rPr>
-              <a:t>10</a:t>
+              <a:t>16</a:t>
             </a:r>
           </a:p>
         </p:txBody>
@@ -6680,8 +6680,8 @@
         </p:nvSpPr>
         <p:spPr>
           <a:xfrm>
-            <a:off x="365760" y="2487168"/>
-            <a:ext cx="1920240" cy="219456"/>
+            <a:off x="320040" y="2103120"/>
+            <a:ext cx="1691640" cy="210312"/>
           </a:xfrm>
           <a:prstGeom prst="rect">
             <a:avLst/>
@@ -6711,8 +6711,8 @@
         </p:nvSpPr>
         <p:spPr>
           <a:xfrm>
-            <a:off x="365760" y="2487168"/>
-            <a:ext cx="1920240" cy="219456"/>
+            <a:off x="320040" y="2103120"/>
+            <a:ext cx="1691640" cy="210312"/>
           </a:xfrm>
           <a:prstGeom prst="rect">
             <a:avLst/>
@@ -6728,7 +6728,7 @@
           <a:p>
             <a:pPr algn="l"/>
             <a:r>
-              <a:rPr lang="en-US" sz="1000" dirty="0" b="1">
+              <a:rPr lang="en-US" sz="800" dirty="0" b="1">
                 <a:solidFill>
                   <a:srgbClr val="06B6D4"/>
                 </a:solidFill>
@@ -6749,8 +6749,8 @@
         </p:nvSpPr>
         <p:spPr>
           <a:xfrm>
-            <a:off x="2377440" y="2487168"/>
-            <a:ext cx="3474720" cy="219456"/>
+            <a:off x="2057400" y="2103120"/>
+            <a:ext cx="2560320" cy="210312"/>
           </a:xfrm>
           <a:prstGeom prst="rect">
             <a:avLst/>
@@ -6766,7 +6766,7 @@
           <a:p>
             <a:pPr algn="l"/>
             <a:r>
-              <a:rPr lang="en-US" sz="1000" dirty="0">
+              <a:rPr lang="en-US" sz="800" dirty="0">
                 <a:solidFill>
                   <a:srgbClr val="F1F5F9"/>
                 </a:solidFill>
@@ -6787,8 +6787,8 @@
         </p:nvSpPr>
         <p:spPr>
           <a:xfrm>
-            <a:off x="365760" y="2724912"/>
-            <a:ext cx="1920240" cy="219456"/>
+            <a:off x="320040" y="2336291"/>
+            <a:ext cx="1691640" cy="210312"/>
           </a:xfrm>
           <a:prstGeom prst="rect">
             <a:avLst/>
@@ -6818,8 +6818,8 @@
         </p:nvSpPr>
         <p:spPr>
           <a:xfrm>
-            <a:off x="365760" y="2724912"/>
-            <a:ext cx="1920240" cy="219456"/>
+            <a:off x="320040" y="2336291"/>
+            <a:ext cx="1691640" cy="210312"/>
           </a:xfrm>
           <a:prstGeom prst="rect">
             <a:avLst/>
@@ -6835,7 +6835,7 @@
           <a:p>
             <a:pPr algn="l"/>
             <a:r>
-              <a:rPr lang="en-US" sz="1000" dirty="0" b="1">
+              <a:rPr lang="en-US" sz="800" dirty="0" b="1">
                 <a:solidFill>
                   <a:srgbClr val="06B6D4"/>
                 </a:solidFill>
@@ -6856,8 +6856,8 @@
         </p:nvSpPr>
         <p:spPr>
           <a:xfrm>
-            <a:off x="2377440" y="2724912"/>
-            <a:ext cx="3474720" cy="219456"/>
+            <a:off x="2057400" y="2336291"/>
+            <a:ext cx="2560320" cy="210312"/>
           </a:xfrm>
           <a:prstGeom prst="rect">
             <a:avLst/>
@@ -6873,13 +6873,13 @@
           <a:p>
             <a:pPr algn="l"/>
             <a:r>
-              <a:rPr lang="en-US" sz="1000" dirty="0">
+              <a:rPr lang="en-US" sz="800" dirty="0">
                 <a:solidFill>
                   <a:srgbClr val="F1F5F9"/>
                 </a:solidFill>
                 <a:latin typeface="Calibri"/>
               </a:rPr>
-              <a:t>Natural-language fault description</a:t>
+              <a:t>Natural-language fault description (7,921 unique)</a:t>
             </a:r>
           </a:p>
         </p:txBody>
@@ -6894,8 +6894,8 @@
         </p:nvSpPr>
         <p:spPr>
           <a:xfrm>
-            <a:off x="365760" y="2962656"/>
-            <a:ext cx="1920240" cy="219456"/>
+            <a:off x="320040" y="2569463"/>
+            <a:ext cx="1691640" cy="210312"/>
           </a:xfrm>
           <a:prstGeom prst="rect">
             <a:avLst/>
@@ -6925,8 +6925,8 @@
         </p:nvSpPr>
         <p:spPr>
           <a:xfrm>
-            <a:off x="365760" y="2962656"/>
-            <a:ext cx="1920240" cy="219456"/>
+            <a:off x="320040" y="2569463"/>
+            <a:ext cx="1691640" cy="210312"/>
           </a:xfrm>
           <a:prstGeom prst="rect">
             <a:avLst/>
@@ -6942,7 +6942,7 @@
           <a:p>
             <a:pPr algn="l"/>
             <a:r>
-              <a:rPr lang="en-US" sz="1000" dirty="0" b="1">
+              <a:rPr lang="en-US" sz="800" dirty="0" b="1">
                 <a:solidFill>
                   <a:srgbClr val="06B6D4"/>
                 </a:solidFill>
@@ -6963,8 +6963,8 @@
         </p:nvSpPr>
         <p:spPr>
           <a:xfrm>
-            <a:off x="2377440" y="2962656"/>
-            <a:ext cx="3474720" cy="219456"/>
+            <a:off x="2057400" y="2569463"/>
+            <a:ext cx="2560320" cy="210312"/>
           </a:xfrm>
           <a:prstGeom prst="rect">
             <a:avLst/>
@@ -6980,7 +6980,7 @@
           <a:p>
             <a:pPr algn="l"/>
             <a:r>
-              <a:rPr lang="en-US" sz="1000" dirty="0">
+              <a:rPr lang="en-US" sz="800" dirty="0">
                 <a:solidFill>
                   <a:srgbClr val="F1F5F9"/>
                 </a:solidFill>
@@ -7001,8 +7001,8 @@
         </p:nvSpPr>
         <p:spPr>
           <a:xfrm>
-            <a:off x="365760" y="3200400"/>
-            <a:ext cx="1920240" cy="219456"/>
+            <a:off x="320040" y="2802636"/>
+            <a:ext cx="1691640" cy="210312"/>
           </a:xfrm>
           <a:prstGeom prst="rect">
             <a:avLst/>
@@ -7032,8 +7032,8 @@
         </p:nvSpPr>
         <p:spPr>
           <a:xfrm>
-            <a:off x="365760" y="3200400"/>
-            <a:ext cx="1920240" cy="219456"/>
+            <a:off x="320040" y="2802636"/>
+            <a:ext cx="1691640" cy="210312"/>
           </a:xfrm>
           <a:prstGeom prst="rect">
             <a:avLst/>
@@ -7049,7 +7049,7 @@
           <a:p>
             <a:pPr algn="l"/>
             <a:r>
-              <a:rPr lang="en-US" sz="1000" dirty="0" b="1">
+              <a:rPr lang="en-US" sz="800" dirty="0" b="1">
                 <a:solidFill>
                   <a:srgbClr val="06B6D4"/>
                 </a:solidFill>
@@ -7070,8 +7070,8 @@
         </p:nvSpPr>
         <p:spPr>
           <a:xfrm>
-            <a:off x="2377440" y="3200400"/>
-            <a:ext cx="3474720" cy="219456"/>
+            <a:off x="2057400" y="2802636"/>
+            <a:ext cx="2560320" cy="210312"/>
           </a:xfrm>
           <a:prstGeom prst="rect">
             <a:avLst/>
@@ -7087,7 +7087,7 @@
           <a:p>
             <a:pPr algn="l"/>
             <a:r>
-              <a:rPr lang="en-US" sz="1000" dirty="0">
+              <a:rPr lang="en-US" sz="800" dirty="0">
                 <a:solidFill>
                   <a:srgbClr val="F1F5F9"/>
                 </a:solidFill>
@@ -7108,8 +7108,8 @@
         </p:nvSpPr>
         <p:spPr>
           <a:xfrm>
-            <a:off x="365760" y="3438144"/>
-            <a:ext cx="1920240" cy="219456"/>
+            <a:off x="320040" y="3035808"/>
+            <a:ext cx="1691640" cy="210312"/>
           </a:xfrm>
           <a:prstGeom prst="rect">
             <a:avLst/>
@@ -7139,8 +7139,8 @@
         </p:nvSpPr>
         <p:spPr>
           <a:xfrm>
-            <a:off x="365760" y="3438144"/>
-            <a:ext cx="1920240" cy="219456"/>
+            <a:off x="320040" y="3035808"/>
+            <a:ext cx="1691640" cy="210312"/>
           </a:xfrm>
           <a:prstGeom prst="rect">
             <a:avLst/>
@@ -7156,7 +7156,7 @@
           <a:p>
             <a:pPr algn="l"/>
             <a:r>
-              <a:rPr lang="en-US" sz="1000" dirty="0" b="1">
+              <a:rPr lang="en-US" sz="800" dirty="0" b="1">
                 <a:solidFill>
                   <a:srgbClr val="06B6D4"/>
                 </a:solidFill>
@@ -7177,8 +7177,8 @@
         </p:nvSpPr>
         <p:spPr>
           <a:xfrm>
-            <a:off x="2377440" y="3438144"/>
-            <a:ext cx="3474720" cy="219456"/>
+            <a:off x="2057400" y="3035808"/>
+            <a:ext cx="2560320" cy="210312"/>
           </a:xfrm>
           <a:prstGeom prst="rect">
             <a:avLst/>
@@ -7194,7 +7194,7 @@
           <a:p>
             <a:pPr algn="l"/>
             <a:r>
-              <a:rPr lang="en-US" sz="1000" dirty="0">
+              <a:rPr lang="en-US" sz="800" dirty="0">
                 <a:solidFill>
                   <a:srgbClr val="F1F5F9"/>
                 </a:solidFill>
@@ -7215,8 +7215,8 @@
         </p:nvSpPr>
         <p:spPr>
           <a:xfrm>
-            <a:off x="365760" y="3675888"/>
-            <a:ext cx="1920240" cy="219456"/>
+            <a:off x="320040" y="3268979"/>
+            <a:ext cx="1691640" cy="210312"/>
           </a:xfrm>
           <a:prstGeom prst="rect">
             <a:avLst/>
@@ -7246,8 +7246,8 @@
         </p:nvSpPr>
         <p:spPr>
           <a:xfrm>
-            <a:off x="365760" y="3675888"/>
-            <a:ext cx="1920240" cy="219456"/>
+            <a:off x="320040" y="3268979"/>
+            <a:ext cx="1691640" cy="210312"/>
           </a:xfrm>
           <a:prstGeom prst="rect">
             <a:avLst/>
@@ -7263,7 +7263,7 @@
           <a:p>
             <a:pPr algn="l"/>
             <a:r>
-              <a:rPr lang="en-US" sz="1000" dirty="0" b="1">
+              <a:rPr lang="en-US" sz="800" dirty="0" b="1">
                 <a:solidFill>
                   <a:srgbClr val="06B6D4"/>
                 </a:solidFill>
@@ -7284,8 +7284,8 @@
         </p:nvSpPr>
         <p:spPr>
           <a:xfrm>
-            <a:off x="2377440" y="3675888"/>
-            <a:ext cx="3474720" cy="219456"/>
+            <a:off x="2057400" y="3268979"/>
+            <a:ext cx="2560320" cy="210312"/>
           </a:xfrm>
           <a:prstGeom prst="rect">
             <a:avLst/>
@@ -7301,7 +7301,7 @@
           <a:p>
             <a:pPr algn="l"/>
             <a:r>
-              <a:rPr lang="en-US" sz="1000" dirty="0">
+              <a:rPr lang="en-US" sz="800" dirty="0">
                 <a:solidFill>
                   <a:srgbClr val="F1F5F9"/>
                 </a:solidFill>
@@ -7322,8 +7322,8 @@
         </p:nvSpPr>
         <p:spPr>
           <a:xfrm>
-            <a:off x="365760" y="3913632"/>
-            <a:ext cx="1920240" cy="219456"/>
+            <a:off x="320040" y="3502152"/>
+            <a:ext cx="1691640" cy="210312"/>
           </a:xfrm>
           <a:prstGeom prst="rect">
             <a:avLst/>
@@ -7353,8 +7353,8 @@
         </p:nvSpPr>
         <p:spPr>
           <a:xfrm>
-            <a:off x="365760" y="3913632"/>
-            <a:ext cx="1920240" cy="219456"/>
+            <a:off x="320040" y="3502152"/>
+            <a:ext cx="1691640" cy="210312"/>
           </a:xfrm>
           <a:prstGeom prst="rect">
             <a:avLst/>
@@ -7370,7 +7370,7 @@
           <a:p>
             <a:pPr algn="l"/>
             <a:r>
-              <a:rPr lang="en-US" sz="1000" dirty="0" b="1">
+              <a:rPr lang="en-US" sz="800" dirty="0" b="1">
                 <a:solidFill>
                   <a:srgbClr val="06B6D4"/>
                 </a:solidFill>
@@ -7391,8 +7391,8 @@
         </p:nvSpPr>
         <p:spPr>
           <a:xfrm>
-            <a:off x="2377440" y="3913632"/>
-            <a:ext cx="3474720" cy="219456"/>
+            <a:off x="2057400" y="3502152"/>
+            <a:ext cx="2560320" cy="210312"/>
           </a:xfrm>
           <a:prstGeom prst="rect">
             <a:avLst/>
@@ -7408,7 +7408,7 @@
           <a:p>
             <a:pPr algn="l"/>
             <a:r>
-              <a:rPr lang="en-US" sz="1000" dirty="0">
+              <a:rPr lang="en-US" sz="800" dirty="0">
                 <a:solidFill>
                   <a:srgbClr val="F1F5F9"/>
                 </a:solidFill>
@@ -7429,8 +7429,8 @@
         </p:nvSpPr>
         <p:spPr>
           <a:xfrm>
-            <a:off x="365760" y="4151376"/>
-            <a:ext cx="1920240" cy="219456"/>
+            <a:off x="320040" y="3735324"/>
+            <a:ext cx="1691640" cy="210312"/>
           </a:xfrm>
           <a:prstGeom prst="rect">
             <a:avLst/>
@@ -7460,8 +7460,8 @@
         </p:nvSpPr>
         <p:spPr>
           <a:xfrm>
-            <a:off x="365760" y="4151376"/>
-            <a:ext cx="1920240" cy="219456"/>
+            <a:off x="320040" y="3735324"/>
+            <a:ext cx="1691640" cy="210312"/>
           </a:xfrm>
           <a:prstGeom prst="rect">
             <a:avLst/>
@@ -7477,7 +7477,7 @@
           <a:p>
             <a:pPr algn="l"/>
             <a:r>
-              <a:rPr lang="en-US" sz="1000" dirty="0" b="1">
+              <a:rPr lang="en-US" sz="800" dirty="0" b="1">
                 <a:solidFill>
                   <a:srgbClr val="06B6D4"/>
                 </a:solidFill>
@@ -7498,8 +7498,8 @@
         </p:nvSpPr>
         <p:spPr>
           <a:xfrm>
-            <a:off x="2377440" y="4151376"/>
-            <a:ext cx="3474720" cy="219456"/>
+            <a:off x="2057400" y="3735324"/>
+            <a:ext cx="2560320" cy="210312"/>
           </a:xfrm>
           <a:prstGeom prst="rect">
             <a:avLst/>
@@ -7515,13 +7515,13 @@
           <a:p>
             <a:pPr algn="l"/>
             <a:r>
-              <a:rPr lang="en-US" sz="1000" dirty="0">
+              <a:rPr lang="en-US" sz="800" dirty="0">
                 <a:solidFill>
                   <a:srgbClr val="F1F5F9"/>
                 </a:solidFill>
                 <a:latin typeface="Calibri"/>
               </a:rPr>
-              <a:t>How the incident was resolved</a:t>
+              <a:t>How the incident was resolved (401 unique)</a:t>
             </a:r>
           </a:p>
         </p:txBody>
@@ -7536,8 +7536,8 @@
         </p:nvSpPr>
         <p:spPr>
           <a:xfrm>
-            <a:off x="365760" y="4389120"/>
-            <a:ext cx="1920240" cy="219456"/>
+            <a:off x="4754880" y="2103120"/>
+            <a:ext cx="1691640" cy="210312"/>
           </a:xfrm>
           <a:prstGeom prst="rect">
             <a:avLst/>
@@ -7567,8 +7567,8 @@
         </p:nvSpPr>
         <p:spPr>
           <a:xfrm>
-            <a:off x="365760" y="4389120"/>
-            <a:ext cx="1920240" cy="219456"/>
+            <a:off x="4754880" y="2103120"/>
+            <a:ext cx="1691640" cy="210312"/>
           </a:xfrm>
           <a:prstGeom prst="rect">
             <a:avLst/>
@@ -7584,9 +7584,9 @@
           <a:p>
             <a:pPr algn="l"/>
             <a:r>
-              <a:rPr lang="en-US" sz="1000" dirty="0" b="1">
-                <a:solidFill>
-                  <a:srgbClr val="06B6D4"/>
+              <a:rPr lang="en-US" sz="800" dirty="0" b="1">
+                <a:solidFill>
+                  <a:srgbClr val="22C55E"/>
                 </a:solidFill>
                 <a:latin typeface="Calibri"/>
               </a:rPr>
@@ -7605,8 +7605,8 @@
         </p:nvSpPr>
         <p:spPr>
           <a:xfrm>
-            <a:off x="2377440" y="4389120"/>
-            <a:ext cx="3474720" cy="219456"/>
+            <a:off x="6492240" y="2103120"/>
+            <a:ext cx="2560320" cy="210312"/>
           </a:xfrm>
           <a:prstGeom prst="rect">
             <a:avLst/>
@@ -7622,7 +7622,7 @@
           <a:p>
             <a:pPr algn="l"/>
             <a:r>
-              <a:rPr lang="en-US" sz="1000" dirty="0">
+              <a:rPr lang="en-US" sz="800" dirty="0">
                 <a:solidFill>
                   <a:srgbClr val="F1F5F9"/>
                 </a:solidFill>
@@ -7643,8 +7643,8 @@
         </p:nvSpPr>
         <p:spPr>
           <a:xfrm>
-            <a:off x="365760" y="4626864"/>
-            <a:ext cx="1920240" cy="219456"/>
+            <a:off x="4754880" y="2336291"/>
+            <a:ext cx="1691640" cy="210312"/>
           </a:xfrm>
           <a:prstGeom prst="rect">
             <a:avLst/>
@@ -7674,8 +7674,8 @@
         </p:nvSpPr>
         <p:spPr>
           <a:xfrm>
-            <a:off x="365760" y="4626864"/>
-            <a:ext cx="1920240" cy="219456"/>
+            <a:off x="4754880" y="2336291"/>
+            <a:ext cx="1691640" cy="210312"/>
           </a:xfrm>
           <a:prstGeom prst="rect">
             <a:avLst/>
@@ -7691,9 +7691,9 @@
           <a:p>
             <a:pPr algn="l"/>
             <a:r>
-              <a:rPr lang="en-US" sz="1000" dirty="0" b="1">
-                <a:solidFill>
-                  <a:srgbClr val="06B6D4"/>
+              <a:rPr lang="en-US" sz="800" dirty="0" b="1">
+                <a:solidFill>
+                  <a:srgbClr val="22C55E"/>
                 </a:solidFill>
                 <a:latin typeface="Calibri"/>
               </a:rPr>
@@ -7712,8 +7712,8 @@
         </p:nvSpPr>
         <p:spPr>
           <a:xfrm>
-            <a:off x="2377440" y="4626864"/>
-            <a:ext cx="3474720" cy="219456"/>
+            <a:off x="6492240" y="2336291"/>
+            <a:ext cx="2560320" cy="210312"/>
           </a:xfrm>
           <a:prstGeom prst="rect">
             <a:avLst/>
@@ -7729,7 +7729,7 @@
           <a:p>
             <a:pPr algn="l"/>
             <a:r>
-              <a:rPr lang="en-US" sz="1000" dirty="0">
+              <a:rPr lang="en-US" sz="800" dirty="0">
                 <a:solidFill>
                   <a:srgbClr val="F1F5F9"/>
                 </a:solidFill>
@@ -7742,40 +7742,33 @@
       </p:sp>
       <p:sp>
         <p:nvSpPr>
-          <p:cNvPr id="52" name="sp52"/>
-          <p:cNvSpPr>
-            <a:spLocks noGrp="1"/>
-          </p:cNvSpPr>
-          <p:nvPr/>
-        </p:nvSpPr>
-        <p:spPr>
-          <a:xfrm>
-            <a:off x="6309360" y="2103120"/>
-            <a:ext cx="2377440" cy="320040"/>
-          </a:xfrm>
-          <a:prstGeom prst="rect">
-            <a:avLst/>
-          </a:prstGeom>
-          <a:noFill/>
-          <a:ln>
-            <a:noFill/>
-          </a:ln>
-        </p:spPr>
-        <p:txBody>
-          <a:bodyPr wrap="square" anchor="t" insFav="0"/>
-          <a:lstStyle/>
-          <a:p>
-            <a:pPr algn="l"/>
-            <a:r>
-              <a:rPr lang="en-US" sz="1300" dirty="0" b="1">
-                <a:solidFill>
-                  <a:srgbClr val="EAB308"/>
-                </a:solidFill>
-                <a:latin typeface="Calibri"/>
-              </a:rPr>
-              <a:t>Sample Record</a:t>
-            </a:r>
-          </a:p>
+          <p:cNvPr id="52" name="rect52"/>
+          <p:cNvSpPr>
+            <a:spLocks noGrp="1"/>
+          </p:cNvSpPr>
+          <p:nvPr/>
+        </p:nvSpPr>
+        <p:spPr>
+          <a:xfrm>
+            <a:off x="4754880" y="2569463"/>
+            <a:ext cx="1691640" cy="210312"/>
+          </a:xfrm>
+          <a:prstGeom prst="rect">
+            <a:avLst/>
+          </a:prstGeom>
+          <a:solidFill>
+            <a:srgbClr val="1E293B"/>
+          </a:solidFill>
+          <a:ln w="12700">
+            <a:solidFill>
+              <a:srgbClr val="334155"/>
+            </a:solidFill>
+          </a:ln>
+        </p:spPr>
+        <p:txBody>
+          <a:bodyPr/>
+          <a:lstStyle/>
+          <a:p/>
         </p:txBody>
       </p:sp>
       <p:sp>
@@ -7788,524 +7781,672 @@
         </p:nvSpPr>
         <p:spPr>
           <a:xfrm>
-            <a:off x="6309360" y="2487168"/>
-            <a:ext cx="1005840" cy="274320"/>
-          </a:xfrm>
-          <a:prstGeom prst="rect">
-            <a:avLst/>
-          </a:prstGeom>
-          <a:noFill/>
-          <a:ln>
-            <a:noFill/>
-          </a:ln>
-        </p:spPr>
-        <p:txBody>
-          <a:bodyPr wrap="square" anchor="t" insFav="0"/>
-          <a:lstStyle/>
-          <a:p>
-            <a:pPr algn="l"/>
+            <a:off x="4754880" y="2569463"/>
+            <a:ext cx="1691640" cy="210312"/>
+          </a:xfrm>
+          <a:prstGeom prst="rect">
+            <a:avLst/>
+          </a:prstGeom>
+          <a:noFill/>
+          <a:ln>
+            <a:noFill/>
+          </a:ln>
+        </p:spPr>
+        <p:txBody>
+          <a:bodyPr wrap="square" anchor="ctr" insFav="0"/>
+          <a:lstStyle/>
+          <a:p>
+            <a:pPr algn="l"/>
+            <a:r>
+              <a:rPr lang="en-US" sz="800" dirty="0" b="1">
+                <a:solidFill>
+                  <a:srgbClr val="22C55E"/>
+                </a:solidFill>
+                <a:latin typeface="Calibri"/>
+              </a:rPr>
+              <a:t>root_cause_category</a:t>
+            </a:r>
+          </a:p>
+        </p:txBody>
+      </p:sp>
+      <p:sp>
+        <p:nvSpPr>
+          <p:cNvPr id="54" name="sp54"/>
+          <p:cNvSpPr>
+            <a:spLocks noGrp="1"/>
+          </p:cNvSpPr>
+          <p:nvPr/>
+        </p:nvSpPr>
+        <p:spPr>
+          <a:xfrm>
+            <a:off x="6492240" y="2569463"/>
+            <a:ext cx="2560320" cy="210312"/>
+          </a:xfrm>
+          <a:prstGeom prst="rect">
+            <a:avLst/>
+          </a:prstGeom>
+          <a:noFill/>
+          <a:ln>
+            <a:noFill/>
+          </a:ln>
+        </p:spPr>
+        <p:txBody>
+          <a:bodyPr wrap="square" anchor="ctr" insFav="0"/>
+          <a:lstStyle/>
+          <a:p>
+            <a:pPr algn="l"/>
+            <a:r>
+              <a:rPr lang="en-US" sz="800" dirty="0">
+                <a:solidFill>
+                  <a:srgbClr val="F1F5F9"/>
+                </a:solidFill>
+                <a:latin typeface="Calibri"/>
+              </a:rPr>
+              <a:t>10 enriched fault categories for RCA</a:t>
+            </a:r>
+          </a:p>
+        </p:txBody>
+      </p:sp>
+      <p:sp>
+        <p:nvSpPr>
+          <p:cNvPr id="55" name="rect55"/>
+          <p:cNvSpPr>
+            <a:spLocks noGrp="1"/>
+          </p:cNvSpPr>
+          <p:nvPr/>
+        </p:nvSpPr>
+        <p:spPr>
+          <a:xfrm>
+            <a:off x="4754880" y="2802636"/>
+            <a:ext cx="1691640" cy="210312"/>
+          </a:xfrm>
+          <a:prstGeom prst="rect">
+            <a:avLst/>
+          </a:prstGeom>
+          <a:solidFill>
+            <a:srgbClr val="1E293B"/>
+          </a:solidFill>
+          <a:ln w="12700">
+            <a:solidFill>
+              <a:srgbClr val="334155"/>
+            </a:solidFill>
+          </a:ln>
+        </p:spPr>
+        <p:txBody>
+          <a:bodyPr/>
+          <a:lstStyle/>
+          <a:p/>
+        </p:txBody>
+      </p:sp>
+      <p:sp>
+        <p:nvSpPr>
+          <p:cNvPr id="56" name="sp56"/>
+          <p:cNvSpPr>
+            <a:spLocks noGrp="1"/>
+          </p:cNvSpPr>
+          <p:nvPr/>
+        </p:nvSpPr>
+        <p:spPr>
+          <a:xfrm>
+            <a:off x="4754880" y="2802636"/>
+            <a:ext cx="1691640" cy="210312"/>
+          </a:xfrm>
+          <a:prstGeom prst="rect">
+            <a:avLst/>
+          </a:prstGeom>
+          <a:noFill/>
+          <a:ln>
+            <a:noFill/>
+          </a:ln>
+        </p:spPr>
+        <p:txBody>
+          <a:bodyPr wrap="square" anchor="ctr" insFav="0"/>
+          <a:lstStyle/>
+          <a:p>
+            <a:pPr algn="l"/>
+            <a:r>
+              <a:rPr lang="en-US" sz="800" dirty="0" b="1">
+                <a:solidFill>
+                  <a:srgbClr val="22C55E"/>
+                </a:solidFill>
+                <a:latin typeface="Calibri"/>
+              </a:rPr>
+              <a:t>root_cause_detail</a:t>
+            </a:r>
+          </a:p>
+        </p:txBody>
+      </p:sp>
+      <p:sp>
+        <p:nvSpPr>
+          <p:cNvPr id="57" name="sp57"/>
+          <p:cNvSpPr>
+            <a:spLocks noGrp="1"/>
+          </p:cNvSpPr>
+          <p:nvPr/>
+        </p:nvSpPr>
+        <p:spPr>
+          <a:xfrm>
+            <a:off x="6492240" y="2802636"/>
+            <a:ext cx="2560320" cy="210312"/>
+          </a:xfrm>
+          <a:prstGeom prst="rect">
+            <a:avLst/>
+          </a:prstGeom>
+          <a:noFill/>
+          <a:ln>
+            <a:noFill/>
+          </a:ln>
+        </p:spPr>
+        <p:txBody>
+          <a:bodyPr wrap="square" anchor="ctr" insFav="0"/>
+          <a:lstStyle/>
+          <a:p>
+            <a:pPr algn="l"/>
+            <a:r>
+              <a:rPr lang="en-US" sz="800" dirty="0">
+                <a:solidFill>
+                  <a:srgbClr val="F1F5F9"/>
+                </a:solidFill>
+                <a:latin typeface="Calibri"/>
+              </a:rPr>
+              <a:t>Specific cause detail per incident</a:t>
+            </a:r>
+          </a:p>
+        </p:txBody>
+      </p:sp>
+      <p:sp>
+        <p:nvSpPr>
+          <p:cNvPr id="58" name="rect58"/>
+          <p:cNvSpPr>
+            <a:spLocks noGrp="1"/>
+          </p:cNvSpPr>
+          <p:nvPr/>
+        </p:nvSpPr>
+        <p:spPr>
+          <a:xfrm>
+            <a:off x="4754880" y="3035808"/>
+            <a:ext cx="1691640" cy="210312"/>
+          </a:xfrm>
+          <a:prstGeom prst="rect">
+            <a:avLst/>
+          </a:prstGeom>
+          <a:solidFill>
+            <a:srgbClr val="1E293B"/>
+          </a:solidFill>
+          <a:ln w="12700">
+            <a:solidFill>
+              <a:srgbClr val="334155"/>
+            </a:solidFill>
+          </a:ln>
+        </p:spPr>
+        <p:txBody>
+          <a:bodyPr/>
+          <a:lstStyle/>
+          <a:p/>
+        </p:txBody>
+      </p:sp>
+      <p:sp>
+        <p:nvSpPr>
+          <p:cNvPr id="59" name="sp59"/>
+          <p:cNvSpPr>
+            <a:spLocks noGrp="1"/>
+          </p:cNvSpPr>
+          <p:nvPr/>
+        </p:nvSpPr>
+        <p:spPr>
+          <a:xfrm>
+            <a:off x="4754880" y="3035808"/>
+            <a:ext cx="1691640" cy="210312"/>
+          </a:xfrm>
+          <a:prstGeom prst="rect">
+            <a:avLst/>
+          </a:prstGeom>
+          <a:noFill/>
+          <a:ln>
+            <a:noFill/>
+          </a:ln>
+        </p:spPr>
+        <p:txBody>
+          <a:bodyPr wrap="square" anchor="ctr" insFav="0"/>
+          <a:lstStyle/>
+          <a:p>
+            <a:pPr algn="l"/>
+            <a:r>
+              <a:rPr lang="en-US" sz="800" dirty="0" b="1">
+                <a:solidFill>
+                  <a:srgbClr val="22C55E"/>
+                </a:solidFill>
+                <a:latin typeface="Calibri"/>
+              </a:rPr>
+              <a:t>fault_component</a:t>
+            </a:r>
+          </a:p>
+        </p:txBody>
+      </p:sp>
+      <p:sp>
+        <p:nvSpPr>
+          <p:cNvPr id="60" name="sp60"/>
+          <p:cNvSpPr>
+            <a:spLocks noGrp="1"/>
+          </p:cNvSpPr>
+          <p:nvPr/>
+        </p:nvSpPr>
+        <p:spPr>
+          <a:xfrm>
+            <a:off x="6492240" y="3035808"/>
+            <a:ext cx="2560320" cy="210312"/>
+          </a:xfrm>
+          <a:prstGeom prst="rect">
+            <a:avLst/>
+          </a:prstGeom>
+          <a:noFill/>
+          <a:ln>
+            <a:noFill/>
+          </a:ln>
+        </p:spPr>
+        <p:txBody>
+          <a:bodyPr wrap="square" anchor="ctr" insFav="0"/>
+          <a:lstStyle/>
+          <a:p>
+            <a:pPr algn="l"/>
+            <a:r>
+              <a:rPr lang="en-US" sz="800" dirty="0">
+                <a:solidFill>
+                  <a:srgbClr val="F1F5F9"/>
+                </a:solidFill>
+                <a:latin typeface="Calibri"/>
+              </a:rPr>
+              <a:t>Vendor-specific component name</a:t>
+            </a:r>
+          </a:p>
+        </p:txBody>
+      </p:sp>
+      <p:sp>
+        <p:nvSpPr>
+          <p:cNvPr id="61" name="rect61"/>
+          <p:cNvSpPr>
+            <a:spLocks noGrp="1"/>
+          </p:cNvSpPr>
+          <p:nvPr/>
+        </p:nvSpPr>
+        <p:spPr>
+          <a:xfrm>
+            <a:off x="4754880" y="3268979"/>
+            <a:ext cx="1691640" cy="210312"/>
+          </a:xfrm>
+          <a:prstGeom prst="rect">
+            <a:avLst/>
+          </a:prstGeom>
+          <a:solidFill>
+            <a:srgbClr val="1E293B"/>
+          </a:solidFill>
+          <a:ln w="12700">
+            <a:solidFill>
+              <a:srgbClr val="334155"/>
+            </a:solidFill>
+          </a:ln>
+        </p:spPr>
+        <p:txBody>
+          <a:bodyPr/>
+          <a:lstStyle/>
+          <a:p/>
+        </p:txBody>
+      </p:sp>
+      <p:sp>
+        <p:nvSpPr>
+          <p:cNvPr id="62" name="sp62"/>
+          <p:cNvSpPr>
+            <a:spLocks noGrp="1"/>
+          </p:cNvSpPr>
+          <p:nvPr/>
+        </p:nvSpPr>
+        <p:spPr>
+          <a:xfrm>
+            <a:off x="4754880" y="3268979"/>
+            <a:ext cx="1691640" cy="210312"/>
+          </a:xfrm>
+          <a:prstGeom prst="rect">
+            <a:avLst/>
+          </a:prstGeom>
+          <a:noFill/>
+          <a:ln>
+            <a:noFill/>
+          </a:ln>
+        </p:spPr>
+        <p:txBody>
+          <a:bodyPr wrap="square" anchor="ctr" insFav="0"/>
+          <a:lstStyle/>
+          <a:p>
+            <a:pPr algn="l"/>
+            <a:r>
+              <a:rPr lang="en-US" sz="800" dirty="0" b="1">
+                <a:solidFill>
+                  <a:srgbClr val="22C55E"/>
+                </a:solidFill>
+                <a:latin typeface="Calibri"/>
+              </a:rPr>
+              <a:t>affected_layer</a:t>
+            </a:r>
+          </a:p>
+        </p:txBody>
+      </p:sp>
+      <p:sp>
+        <p:nvSpPr>
+          <p:cNvPr id="63" name="sp63"/>
+          <p:cNvSpPr>
+            <a:spLocks noGrp="1"/>
+          </p:cNvSpPr>
+          <p:nvPr/>
+        </p:nvSpPr>
+        <p:spPr>
+          <a:xfrm>
+            <a:off x="6492240" y="3268979"/>
+            <a:ext cx="2560320" cy="210312"/>
+          </a:xfrm>
+          <a:prstGeom prst="rect">
+            <a:avLst/>
+          </a:prstGeom>
+          <a:noFill/>
+          <a:ln>
+            <a:noFill/>
+          </a:ln>
+        </p:spPr>
+        <p:txBody>
+          <a:bodyPr wrap="square" anchor="ctr" insFav="0"/>
+          <a:lstStyle/>
+          <a:p>
+            <a:pPr algn="l"/>
+            <a:r>
+              <a:rPr lang="en-US" sz="800" dirty="0">
+                <a:solidFill>
+                  <a:srgbClr val="F1F5F9"/>
+                </a:solidFill>
+                <a:latin typeface="Calibri"/>
+              </a:rPr>
+              <a:t>Radio / Core / Transport / Mixed</a:t>
+            </a:r>
+          </a:p>
+        </p:txBody>
+      </p:sp>
+      <p:sp>
+        <p:nvSpPr>
+          <p:cNvPr id="64" name="rect64"/>
+          <p:cNvSpPr>
+            <a:spLocks noGrp="1"/>
+          </p:cNvSpPr>
+          <p:nvPr/>
+        </p:nvSpPr>
+        <p:spPr>
+          <a:xfrm>
+            <a:off x="4754880" y="3502152"/>
+            <a:ext cx="1691640" cy="210312"/>
+          </a:xfrm>
+          <a:prstGeom prst="rect">
+            <a:avLst/>
+          </a:prstGeom>
+          <a:solidFill>
+            <a:srgbClr val="1E293B"/>
+          </a:solidFill>
+          <a:ln w="12700">
+            <a:solidFill>
+              <a:srgbClr val="334155"/>
+            </a:solidFill>
+          </a:ln>
+        </p:spPr>
+        <p:txBody>
+          <a:bodyPr/>
+          <a:lstStyle/>
+          <a:p/>
+        </p:txBody>
+      </p:sp>
+      <p:sp>
+        <p:nvSpPr>
+          <p:cNvPr id="65" name="sp65"/>
+          <p:cNvSpPr>
+            <a:spLocks noGrp="1"/>
+          </p:cNvSpPr>
+          <p:nvPr/>
+        </p:nvSpPr>
+        <p:spPr>
+          <a:xfrm>
+            <a:off x="4754880" y="3502152"/>
+            <a:ext cx="1691640" cy="210312"/>
+          </a:xfrm>
+          <a:prstGeom prst="rect">
+            <a:avLst/>
+          </a:prstGeom>
+          <a:noFill/>
+          <a:ln>
+            <a:noFill/>
+          </a:ln>
+        </p:spPr>
+        <p:txBody>
+          <a:bodyPr wrap="square" anchor="ctr" insFav="0"/>
+          <a:lstStyle/>
+          <a:p>
+            <a:pPr algn="l"/>
+            <a:r>
+              <a:rPr lang="en-US" sz="800" dirty="0" b="1">
+                <a:solidFill>
+                  <a:srgbClr val="22C55E"/>
+                </a:solidFill>
+                <a:latin typeface="Calibri"/>
+              </a:rPr>
+              <a:t>symptom_keywords</a:t>
+            </a:r>
+          </a:p>
+        </p:txBody>
+      </p:sp>
+      <p:sp>
+        <p:nvSpPr>
+          <p:cNvPr id="66" name="sp66"/>
+          <p:cNvSpPr>
+            <a:spLocks noGrp="1"/>
+          </p:cNvSpPr>
+          <p:nvPr/>
+        </p:nvSpPr>
+        <p:spPr>
+          <a:xfrm>
+            <a:off x="6492240" y="3502152"/>
+            <a:ext cx="2560320" cy="210312"/>
+          </a:xfrm>
+          <a:prstGeom prst="rect">
+            <a:avLst/>
+          </a:prstGeom>
+          <a:noFill/>
+          <a:ln>
+            <a:noFill/>
+          </a:ln>
+        </p:spPr>
+        <p:txBody>
+          <a:bodyPr wrap="square" anchor="ctr" insFav="0"/>
+          <a:lstStyle/>
+          <a:p>
+            <a:pPr algn="l"/>
+            <a:r>
+              <a:rPr lang="en-US" sz="800" dirty="0">
+                <a:solidFill>
+                  <a:srgbClr val="F1F5F9"/>
+                </a:solidFill>
+                <a:latin typeface="Calibri"/>
+              </a:rPr>
+              <a:t>Curated BM25 search terms (2× weight)</a:t>
+            </a:r>
+          </a:p>
+        </p:txBody>
+      </p:sp>
+      <p:sp>
+        <p:nvSpPr>
+          <p:cNvPr id="67" name="rect67"/>
+          <p:cNvSpPr>
+            <a:spLocks noGrp="1"/>
+          </p:cNvSpPr>
+          <p:nvPr/>
+        </p:nvSpPr>
+        <p:spPr>
+          <a:xfrm>
+            <a:off x="4754880" y="3735324"/>
+            <a:ext cx="1691640" cy="210312"/>
+          </a:xfrm>
+          <a:prstGeom prst="rect">
+            <a:avLst/>
+          </a:prstGeom>
+          <a:solidFill>
+            <a:srgbClr val="1E293B"/>
+          </a:solidFill>
+          <a:ln w="12700">
+            <a:solidFill>
+              <a:srgbClr val="334155"/>
+            </a:solidFill>
+          </a:ln>
+        </p:spPr>
+        <p:txBody>
+          <a:bodyPr/>
+          <a:lstStyle/>
+          <a:p/>
+        </p:txBody>
+      </p:sp>
+      <p:sp>
+        <p:nvSpPr>
+          <p:cNvPr id="68" name="sp68"/>
+          <p:cNvSpPr>
+            <a:spLocks noGrp="1"/>
+          </p:cNvSpPr>
+          <p:nvPr/>
+        </p:nvSpPr>
+        <p:spPr>
+          <a:xfrm>
+            <a:off x="4754880" y="3735324"/>
+            <a:ext cx="1691640" cy="210312"/>
+          </a:xfrm>
+          <a:prstGeom prst="rect">
+            <a:avLst/>
+          </a:prstGeom>
+          <a:noFill/>
+          <a:ln>
+            <a:noFill/>
+          </a:ln>
+        </p:spPr>
+        <p:txBody>
+          <a:bodyPr wrap="square" anchor="ctr" insFav="0"/>
+          <a:lstStyle/>
+          <a:p>
+            <a:pPr algn="l"/>
+            <a:r>
+              <a:rPr lang="en-US" sz="800" dirty="0" b="1">
+                <a:solidFill>
+                  <a:srgbClr val="22C55E"/>
+                </a:solidFill>
+                <a:latin typeface="Calibri"/>
+              </a:rPr>
+              <a:t>contributing_factors</a:t>
+            </a:r>
+          </a:p>
+        </p:txBody>
+      </p:sp>
+      <p:sp>
+        <p:nvSpPr>
+          <p:cNvPr id="69" name="sp69"/>
+          <p:cNvSpPr>
+            <a:spLocks noGrp="1"/>
+          </p:cNvSpPr>
+          <p:nvPr/>
+        </p:nvSpPr>
+        <p:spPr>
+          <a:xfrm>
+            <a:off x="6492240" y="3735324"/>
+            <a:ext cx="2560320" cy="210312"/>
+          </a:xfrm>
+          <a:prstGeom prst="rect">
+            <a:avLst/>
+          </a:prstGeom>
+          <a:noFill/>
+          <a:ln>
+            <a:noFill/>
+          </a:ln>
+        </p:spPr>
+        <p:txBody>
+          <a:bodyPr wrap="square" anchor="ctr" insFav="0"/>
+          <a:lstStyle/>
+          <a:p>
+            <a:pPr algn="l"/>
+            <a:r>
+              <a:rPr lang="en-US" sz="800" dirty="0">
+                <a:solidFill>
+                  <a:srgbClr val="F1F5F9"/>
+                </a:solidFill>
+                <a:latin typeface="Calibri"/>
+              </a:rPr>
+              <a:t>Severity + geography + failure chain</a:t>
+            </a:r>
+          </a:p>
+        </p:txBody>
+      </p:sp>
+      <p:sp>
+        <p:nvSpPr>
+          <p:cNvPr id="70" name="rect70"/>
+          <p:cNvSpPr>
+            <a:spLocks noGrp="1"/>
+          </p:cNvSpPr>
+          <p:nvPr/>
+        </p:nvSpPr>
+        <p:spPr>
+          <a:xfrm>
+            <a:off x="4709160" y="1600200"/>
+            <a:ext cx="4297680" cy="411480"/>
+          </a:xfrm>
+          <a:prstGeom prst="rect">
+            <a:avLst/>
+          </a:prstGeom>
+          <a:solidFill>
+            <a:srgbClr val="#1a2e1a"/>
+          </a:solidFill>
+          <a:ln w="12700">
+            <a:solidFill>
+              <a:srgbClr val="22C55E"/>
+            </a:solidFill>
+          </a:ln>
+        </p:spPr>
+        <p:txBody>
+          <a:bodyPr/>
+          <a:lstStyle/>
+          <a:p/>
+        </p:txBody>
+      </p:sp>
+      <p:sp>
+        <p:nvSpPr>
+          <p:cNvPr id="71" name="sp71"/>
+          <p:cNvSpPr>
+            <a:spLocks noGrp="1"/>
+          </p:cNvSpPr>
+          <p:nvPr/>
+        </p:nvSpPr>
+        <p:spPr>
+          <a:xfrm>
+            <a:off x="4709160" y="1600200"/>
+            <a:ext cx="4297680" cy="411480"/>
+          </a:xfrm>
+          <a:prstGeom prst="rect">
+            <a:avLst/>
+          </a:prstGeom>
+          <a:noFill/>
+          <a:ln>
+            <a:noFill/>
+          </a:ln>
+        </p:spPr>
+        <p:txBody>
+          <a:bodyPr wrap="square" anchor="ctr" insFav="0"/>
+          <a:lstStyle/>
+          <a:p>
+            <a:pPr algn="ctr"/>
             <a:r>
               <a:rPr lang="en-US" sz="1100" dirty="0" b="1">
                 <a:solidFill>
-                  <a:srgbClr val="94A3B8"/>
-                </a:solidFill>
-                <a:latin typeface="Calibri"/>
-              </a:rPr>
-              <a:t>Alarm ID:</a:t>
-            </a:r>
-          </a:p>
-        </p:txBody>
-      </p:sp>
-      <p:sp>
-        <p:nvSpPr>
-          <p:cNvPr id="54" name="sp54"/>
-          <p:cNvSpPr>
-            <a:spLocks noGrp="1"/>
-          </p:cNvSpPr>
-          <p:nvPr/>
-        </p:nvSpPr>
-        <p:spPr>
-          <a:xfrm>
-            <a:off x="7360920" y="2487168"/>
-            <a:ext cx="1463040" cy="274320"/>
-          </a:xfrm>
-          <a:prstGeom prst="rect">
-            <a:avLst/>
-          </a:prstGeom>
-          <a:noFill/>
-          <a:ln>
-            <a:noFill/>
-          </a:ln>
-        </p:spPr>
-        <p:txBody>
-          <a:bodyPr wrap="square" anchor="t" insFav="0"/>
-          <a:lstStyle/>
-          <a:p>
-            <a:pPr algn="l"/>
-            <a:r>
-              <a:rPr lang="en-US" sz="1100" dirty="0">
-                <a:solidFill>
-                  <a:srgbClr val="F1F5F9"/>
-                </a:solidFill>
-                <a:latin typeface="Calibri"/>
-              </a:rPr>
-              <a:t>ALM_000042</a:t>
-            </a:r>
-          </a:p>
-        </p:txBody>
-      </p:sp>
-      <p:sp>
-        <p:nvSpPr>
-          <p:cNvPr id="55" name="sp55"/>
-          <p:cNvSpPr>
-            <a:spLocks noGrp="1"/>
-          </p:cNvSpPr>
-          <p:nvPr/>
-        </p:nvSpPr>
-        <p:spPr>
-          <a:xfrm>
-            <a:off x="6309360" y="2798064"/>
-            <a:ext cx="1005840" cy="274320"/>
-          </a:xfrm>
-          <a:prstGeom prst="rect">
-            <a:avLst/>
-          </a:prstGeom>
-          <a:noFill/>
-          <a:ln>
-            <a:noFill/>
-          </a:ln>
-        </p:spPr>
-        <p:txBody>
-          <a:bodyPr wrap="square" anchor="t" insFav="0"/>
-          <a:lstStyle/>
-          <a:p>
-            <a:pPr algn="l"/>
-            <a:r>
-              <a:rPr lang="en-US" sz="1100" dirty="0" b="1">
-                <a:solidFill>
-                  <a:srgbClr val="94A3B8"/>
-                </a:solidFill>
-                <a:latin typeface="Calibri"/>
-              </a:rPr>
-              <a:t>Region:</a:t>
-            </a:r>
-          </a:p>
-        </p:txBody>
-      </p:sp>
-      <p:sp>
-        <p:nvSpPr>
-          <p:cNvPr id="56" name="sp56"/>
-          <p:cNvSpPr>
-            <a:spLocks noGrp="1"/>
-          </p:cNvSpPr>
-          <p:nvPr/>
-        </p:nvSpPr>
-        <p:spPr>
-          <a:xfrm>
-            <a:off x="7360920" y="2798064"/>
-            <a:ext cx="1463040" cy="274320"/>
-          </a:xfrm>
-          <a:prstGeom prst="rect">
-            <a:avLst/>
-          </a:prstGeom>
-          <a:noFill/>
-          <a:ln>
-            <a:noFill/>
-          </a:ln>
-        </p:spPr>
-        <p:txBody>
-          <a:bodyPr wrap="square" anchor="t" insFav="0"/>
-          <a:lstStyle/>
-          <a:p>
-            <a:pPr algn="l"/>
-            <a:r>
-              <a:rPr lang="en-US" sz="1100" dirty="0">
-                <a:solidFill>
-                  <a:srgbClr val="F1F5F9"/>
-                </a:solidFill>
-                <a:latin typeface="Calibri"/>
-              </a:rPr>
-              <a:t>North India</a:t>
-            </a:r>
-          </a:p>
-        </p:txBody>
-      </p:sp>
-      <p:sp>
-        <p:nvSpPr>
-          <p:cNvPr id="57" name="sp57"/>
-          <p:cNvSpPr>
-            <a:spLocks noGrp="1"/>
-          </p:cNvSpPr>
-          <p:nvPr/>
-        </p:nvSpPr>
-        <p:spPr>
-          <a:xfrm>
-            <a:off x="6309360" y="3108960"/>
-            <a:ext cx="1005840" cy="274320"/>
-          </a:xfrm>
-          <a:prstGeom prst="rect">
-            <a:avLst/>
-          </a:prstGeom>
-          <a:noFill/>
-          <a:ln>
-            <a:noFill/>
-          </a:ln>
-        </p:spPr>
-        <p:txBody>
-          <a:bodyPr wrap="square" anchor="t" insFav="0"/>
-          <a:lstStyle/>
-          <a:p>
-            <a:pPr algn="l"/>
-            <a:r>
-              <a:rPr lang="en-US" sz="1100" dirty="0" b="1">
-                <a:solidFill>
-                  <a:srgbClr val="94A3B8"/>
-                </a:solidFill>
-                <a:latin typeface="Calibri"/>
-              </a:rPr>
-              <a:t>Technology:</a:t>
-            </a:r>
-          </a:p>
-        </p:txBody>
-      </p:sp>
-      <p:sp>
-        <p:nvSpPr>
-          <p:cNvPr id="58" name="sp58"/>
-          <p:cNvSpPr>
-            <a:spLocks noGrp="1"/>
-          </p:cNvSpPr>
-          <p:nvPr/>
-        </p:nvSpPr>
-        <p:spPr>
-          <a:xfrm>
-            <a:off x="7360920" y="3108960"/>
-            <a:ext cx="1463040" cy="274320"/>
-          </a:xfrm>
-          <a:prstGeom prst="rect">
-            <a:avLst/>
-          </a:prstGeom>
-          <a:noFill/>
-          <a:ln>
-            <a:noFill/>
-          </a:ln>
-        </p:spPr>
-        <p:txBody>
-          <a:bodyPr wrap="square" anchor="t" insFav="0"/>
-          <a:lstStyle/>
-          <a:p>
-            <a:pPr algn="l"/>
-            <a:r>
-              <a:rPr lang="en-US" sz="1100" dirty="0">
-                <a:solidFill>
-                  <a:srgbClr val="F1F5F9"/>
-                </a:solidFill>
-                <a:latin typeface="Calibri"/>
-              </a:rPr>
-              <a:t>5G</a:t>
-            </a:r>
-          </a:p>
-        </p:txBody>
-      </p:sp>
-      <p:sp>
-        <p:nvSpPr>
-          <p:cNvPr id="59" name="sp59"/>
-          <p:cNvSpPr>
-            <a:spLocks noGrp="1"/>
-          </p:cNvSpPr>
-          <p:nvPr/>
-        </p:nvSpPr>
-        <p:spPr>
-          <a:xfrm>
-            <a:off x="6309360" y="3419856"/>
-            <a:ext cx="1005840" cy="274320"/>
-          </a:xfrm>
-          <a:prstGeom prst="rect">
-            <a:avLst/>
-          </a:prstGeom>
-          <a:noFill/>
-          <a:ln>
-            <a:noFill/>
-          </a:ln>
-        </p:spPr>
-        <p:txBody>
-          <a:bodyPr wrap="square" anchor="t" insFav="0"/>
-          <a:lstStyle/>
-          <a:p>
-            <a:pPr algn="l"/>
-            <a:r>
-              <a:rPr lang="en-US" sz="1100" dirty="0" b="1">
-                <a:solidFill>
-                  <a:srgbClr val="94A3B8"/>
-                </a:solidFill>
-                <a:latin typeface="Calibri"/>
-              </a:rPr>
-              <a:t>Severity:</a:t>
-            </a:r>
-          </a:p>
-        </p:txBody>
-      </p:sp>
-      <p:sp>
-        <p:nvSpPr>
-          <p:cNvPr id="60" name="sp60"/>
-          <p:cNvSpPr>
-            <a:spLocks noGrp="1"/>
-          </p:cNvSpPr>
-          <p:nvPr/>
-        </p:nvSpPr>
-        <p:spPr>
-          <a:xfrm>
-            <a:off x="7360920" y="3419856"/>
-            <a:ext cx="1463040" cy="274320"/>
-          </a:xfrm>
-          <a:prstGeom prst="rect">
-            <a:avLst/>
-          </a:prstGeom>
-          <a:noFill/>
-          <a:ln>
-            <a:noFill/>
-          </a:ln>
-        </p:spPr>
-        <p:txBody>
-          <a:bodyPr wrap="square" anchor="t" insFav="0"/>
-          <a:lstStyle/>
-          <a:p>
-            <a:pPr algn="l"/>
-            <a:r>
-              <a:rPr lang="en-US" sz="1100" dirty="0">
-                <a:solidFill>
-                  <a:srgbClr val="F1F5F9"/>
-                </a:solidFill>
-                <a:latin typeface="Calibri"/>
-              </a:rPr>
-              <a:t>Critical</a:t>
-            </a:r>
-          </a:p>
-        </p:txBody>
-      </p:sp>
-      <p:sp>
-        <p:nvSpPr>
-          <p:cNvPr id="61" name="sp61"/>
-          <p:cNvSpPr>
-            <a:spLocks noGrp="1"/>
-          </p:cNvSpPr>
-          <p:nvPr/>
-        </p:nvSpPr>
-        <p:spPr>
-          <a:xfrm>
-            <a:off x="6309360" y="3730752"/>
-            <a:ext cx="1005840" cy="274320"/>
-          </a:xfrm>
-          <a:prstGeom prst="rect">
-            <a:avLst/>
-          </a:prstGeom>
-          <a:noFill/>
-          <a:ln>
-            <a:noFill/>
-          </a:ln>
-        </p:spPr>
-        <p:txBody>
-          <a:bodyPr wrap="square" anchor="t" insFav="0"/>
-          <a:lstStyle/>
-          <a:p>
-            <a:pPr algn="l"/>
-            <a:r>
-              <a:rPr lang="en-US" sz="1100" dirty="0" b="1">
-                <a:solidFill>
-                  <a:srgbClr val="94A3B8"/>
-                </a:solidFill>
-                <a:latin typeface="Calibri"/>
-              </a:rPr>
-              <a:t>Vendor:</a:t>
-            </a:r>
-          </a:p>
-        </p:txBody>
-      </p:sp>
-      <p:sp>
-        <p:nvSpPr>
-          <p:cNvPr id="62" name="sp62"/>
-          <p:cNvSpPr>
-            <a:spLocks noGrp="1"/>
-          </p:cNvSpPr>
-          <p:nvPr/>
-        </p:nvSpPr>
-        <p:spPr>
-          <a:xfrm>
-            <a:off x="7360920" y="3730752"/>
-            <a:ext cx="1463040" cy="274320"/>
-          </a:xfrm>
-          <a:prstGeom prst="rect">
-            <a:avLst/>
-          </a:prstGeom>
-          <a:noFill/>
-          <a:ln>
-            <a:noFill/>
-          </a:ln>
-        </p:spPr>
-        <p:txBody>
-          <a:bodyPr wrap="square" anchor="t" insFav="0"/>
-          <a:lstStyle/>
-          <a:p>
-            <a:pPr algn="l"/>
-            <a:r>
-              <a:rPr lang="en-US" sz="1100" dirty="0">
-                <a:solidFill>
-                  <a:srgbClr val="F1F5F9"/>
-                </a:solidFill>
-                <a:latin typeface="Calibri"/>
-              </a:rPr>
-              <a:t>Ericsson</a:t>
-            </a:r>
-          </a:p>
-        </p:txBody>
-      </p:sp>
-      <p:sp>
-        <p:nvSpPr>
-          <p:cNvPr id="63" name="sp63"/>
-          <p:cNvSpPr>
-            <a:spLocks noGrp="1"/>
-          </p:cNvSpPr>
-          <p:nvPr/>
-        </p:nvSpPr>
-        <p:spPr>
-          <a:xfrm>
-            <a:off x="6309360" y="4041648"/>
-            <a:ext cx="1005840" cy="274320"/>
-          </a:xfrm>
-          <a:prstGeom prst="rect">
-            <a:avLst/>
-          </a:prstGeom>
-          <a:noFill/>
-          <a:ln>
-            <a:noFill/>
-          </a:ln>
-        </p:spPr>
-        <p:txBody>
-          <a:bodyPr wrap="square" anchor="t" insFav="0"/>
-          <a:lstStyle/>
-          <a:p>
-            <a:pPr algn="l"/>
-            <a:r>
-              <a:rPr lang="en-US" sz="1100" dirty="0" b="1">
-                <a:solidFill>
-                  <a:srgbClr val="94A3B8"/>
-                </a:solidFill>
-                <a:latin typeface="Calibri"/>
-              </a:rPr>
-              <a:t>Duration:</a:t>
-            </a:r>
-          </a:p>
-        </p:txBody>
-      </p:sp>
-      <p:sp>
-        <p:nvSpPr>
-          <p:cNvPr id="64" name="sp64"/>
-          <p:cNvSpPr>
-            <a:spLocks noGrp="1"/>
-          </p:cNvSpPr>
-          <p:nvPr/>
-        </p:nvSpPr>
-        <p:spPr>
-          <a:xfrm>
-            <a:off x="7360920" y="4041648"/>
-            <a:ext cx="1463040" cy="274320"/>
-          </a:xfrm>
-          <a:prstGeom prst="rect">
-            <a:avLst/>
-          </a:prstGeom>
-          <a:noFill/>
-          <a:ln>
-            <a:noFill/>
-          </a:ln>
-        </p:spPr>
-        <p:txBody>
-          <a:bodyPr wrap="square" anchor="t" insFav="0"/>
-          <a:lstStyle/>
-          <a:p>
-            <a:pPr algn="l"/>
-            <a:r>
-              <a:rPr lang="en-US" sz="1100" dirty="0">
-                <a:solidFill>
-                  <a:srgbClr val="F1F5F9"/>
-                </a:solidFill>
-                <a:latin typeface="Calibri"/>
-              </a:rPr>
-              <a:t>87 minutes</a:t>
-            </a:r>
-          </a:p>
-        </p:txBody>
-      </p:sp>
-      <p:sp>
-        <p:nvSpPr>
-          <p:cNvPr id="65" name="sp65"/>
-          <p:cNvSpPr>
-            <a:spLocks noGrp="1"/>
-          </p:cNvSpPr>
-          <p:nvPr/>
-        </p:nvSpPr>
-        <p:spPr>
-          <a:xfrm>
-            <a:off x="6309360" y="4352544"/>
-            <a:ext cx="1005840" cy="274320"/>
-          </a:xfrm>
-          <a:prstGeom prst="rect">
-            <a:avLst/>
-          </a:prstGeom>
-          <a:noFill/>
-          <a:ln>
-            <a:noFill/>
-          </a:ln>
-        </p:spPr>
-        <p:txBody>
-          <a:bodyPr wrap="square" anchor="t" insFav="0"/>
-          <a:lstStyle/>
-          <a:p>
-            <a:pPr algn="l"/>
-            <a:r>
-              <a:rPr lang="en-US" sz="1100" dirty="0" b="1">
-                <a:solidFill>
-                  <a:srgbClr val="94A3B8"/>
-                </a:solidFill>
-                <a:latin typeface="Calibri"/>
-              </a:rPr>
-              <a:t>Impact:</a:t>
-            </a:r>
-          </a:p>
-        </p:txBody>
-      </p:sp>
-      <p:sp>
-        <p:nvSpPr>
-          <p:cNvPr id="66" name="sp66"/>
-          <p:cNvSpPr>
-            <a:spLocks noGrp="1"/>
-          </p:cNvSpPr>
-          <p:nvPr/>
-        </p:nvSpPr>
-        <p:spPr>
-          <a:xfrm>
-            <a:off x="7360920" y="4352544"/>
-            <a:ext cx="1463040" cy="274320"/>
-          </a:xfrm>
-          <a:prstGeom prst="rect">
-            <a:avLst/>
-          </a:prstGeom>
-          <a:noFill/>
-          <a:ln>
-            <a:noFill/>
-          </a:ln>
-        </p:spPr>
-        <p:txBody>
-          <a:bodyPr wrap="square" anchor="t" insFav="0"/>
-          <a:lstStyle/>
-          <a:p>
-            <a:pPr algn="l"/>
-            <a:r>
-              <a:rPr lang="en-US" sz="1100" dirty="0">
-                <a:solidFill>
-                  <a:srgbClr val="F1F5F9"/>
-                </a:solidFill>
-                <a:latin typeface="Calibri"/>
-              </a:rPr>
-              <a:t>Data service loss</a:t>
+                  <a:srgbClr val="22C55E"/>
+                </a:solidFill>
+                <a:latin typeface="Calibri"/>
+              </a:rPr>
+              <a:t>★ 6 NEW Enrichment Columns  |  RCA Confidence: 88–92%</a:t>
             </a:r>
           </a:p>
         </p:txBody>

</xml_diff>